<commit_message>
Fix M03/M04/M05 Slide 7: tighten step spacing to prevent step 8 overlapping clean-up note
</commit_message>
<xml_diff>
--- a/contents/Module-03-Database-Creation-and-Management.pptx
+++ b/contents/Module-03-Database-Creation-and-Management.pptx
@@ -9459,7 +9459,7 @@
         </p:nvSpPr>
         <p:spPr>
           <a:xfrm>
-            <a:off x="640080" y="3310128"/>
+            <a:off x="640080" y="3264408"/>
             <a:ext cx="292608" cy="292608"/>
           </a:xfrm>
           <a:prstGeom prst="rect">
@@ -9502,7 +9502,7 @@
         </p:nvSpPr>
         <p:spPr>
           <a:xfrm>
-            <a:off x="640080" y="3328416"/>
+            <a:off x="640080" y="3282696"/>
             <a:ext cx="292608" cy="256032"/>
           </a:xfrm>
           <a:prstGeom prst="rect">
@@ -9537,7 +9537,7 @@
         </p:nvSpPr>
         <p:spPr>
           <a:xfrm>
-            <a:off x="1051560" y="3291840"/>
+            <a:off x="1051560" y="3246120"/>
             <a:ext cx="6217920" cy="329184"/>
           </a:xfrm>
           <a:prstGeom prst="rect">
@@ -9572,7 +9572,7 @@
         </p:nvSpPr>
         <p:spPr>
           <a:xfrm>
-            <a:off x="640080" y="3767328"/>
+            <a:off x="640080" y="3675888"/>
             <a:ext cx="292608" cy="292608"/>
           </a:xfrm>
           <a:prstGeom prst="rect">
@@ -9615,7 +9615,7 @@
         </p:nvSpPr>
         <p:spPr>
           <a:xfrm>
-            <a:off x="640080" y="3785616"/>
+            <a:off x="640080" y="3694176"/>
             <a:ext cx="292608" cy="256032"/>
           </a:xfrm>
           <a:prstGeom prst="rect">
@@ -9650,7 +9650,7 @@
         </p:nvSpPr>
         <p:spPr>
           <a:xfrm>
-            <a:off x="1051560" y="3749040"/>
+            <a:off x="1051560" y="3657600"/>
             <a:ext cx="6217920" cy="329184"/>
           </a:xfrm>
           <a:prstGeom prst="rect">
@@ -9685,7 +9685,7 @@
         </p:nvSpPr>
         <p:spPr>
           <a:xfrm>
-            <a:off x="640080" y="4224528"/>
+            <a:off x="640080" y="4087368"/>
             <a:ext cx="292608" cy="292608"/>
           </a:xfrm>
           <a:prstGeom prst="rect">
@@ -9728,7 +9728,7 @@
         </p:nvSpPr>
         <p:spPr>
           <a:xfrm>
-            <a:off x="640080" y="4242816"/>
+            <a:off x="640080" y="4105656"/>
             <a:ext cx="292608" cy="256032"/>
           </a:xfrm>
           <a:prstGeom prst="rect">
@@ -9763,7 +9763,7 @@
         </p:nvSpPr>
         <p:spPr>
           <a:xfrm>
-            <a:off x="1051560" y="4206240"/>
+            <a:off x="1051560" y="4069080"/>
             <a:ext cx="6217920" cy="329184"/>
           </a:xfrm>
           <a:prstGeom prst="rect">
@@ -9798,7 +9798,7 @@
         </p:nvSpPr>
         <p:spPr>
           <a:xfrm>
-            <a:off x="640080" y="4681728"/>
+            <a:off x="640080" y="4498848"/>
             <a:ext cx="292608" cy="292608"/>
           </a:xfrm>
           <a:prstGeom prst="rect">
@@ -9841,7 +9841,7 @@
         </p:nvSpPr>
         <p:spPr>
           <a:xfrm>
-            <a:off x="640080" y="4700016"/>
+            <a:off x="640080" y="4517136"/>
             <a:ext cx="292608" cy="256032"/>
           </a:xfrm>
           <a:prstGeom prst="rect">
@@ -9876,7 +9876,7 @@
         </p:nvSpPr>
         <p:spPr>
           <a:xfrm>
-            <a:off x="1051560" y="4663440"/>
+            <a:off x="1051560" y="4480560"/>
             <a:ext cx="6217920" cy="329184"/>
           </a:xfrm>
           <a:prstGeom prst="rect">
@@ -9911,7 +9911,7 @@
         </p:nvSpPr>
         <p:spPr>
           <a:xfrm>
-            <a:off x="640080" y="5138928"/>
+            <a:off x="640080" y="4910328"/>
             <a:ext cx="292608" cy="292608"/>
           </a:xfrm>
           <a:prstGeom prst="rect">
@@ -9954,7 +9954,7 @@
         </p:nvSpPr>
         <p:spPr>
           <a:xfrm>
-            <a:off x="640080" y="5157216"/>
+            <a:off x="640080" y="4928616"/>
             <a:ext cx="292608" cy="256032"/>
           </a:xfrm>
           <a:prstGeom prst="rect">
@@ -9989,7 +9989,7 @@
         </p:nvSpPr>
         <p:spPr>
           <a:xfrm>
-            <a:off x="1051560" y="5120640"/>
+            <a:off x="1051560" y="4892040"/>
             <a:ext cx="6217920" cy="329184"/>
           </a:xfrm>
           <a:prstGeom prst="rect">
@@ -10024,7 +10024,7 @@
         </p:nvSpPr>
         <p:spPr>
           <a:xfrm>
-            <a:off x="640080" y="5596128"/>
+            <a:off x="640080" y="5321808"/>
             <a:ext cx="292608" cy="292608"/>
           </a:xfrm>
           <a:prstGeom prst="rect">
@@ -10067,7 +10067,7 @@
         </p:nvSpPr>
         <p:spPr>
           <a:xfrm>
-            <a:off x="640080" y="5614416"/>
+            <a:off x="640080" y="5340096"/>
             <a:ext cx="292608" cy="256032"/>
           </a:xfrm>
           <a:prstGeom prst="rect">
@@ -10102,7 +10102,7 @@
         </p:nvSpPr>
         <p:spPr>
           <a:xfrm>
-            <a:off x="1051560" y="5577840"/>
+            <a:off x="1051560" y="5303520"/>
             <a:ext cx="6217920" cy="329184"/>
           </a:xfrm>
           <a:prstGeom prst="rect">
@@ -10137,7 +10137,7 @@
         </p:nvSpPr>
         <p:spPr>
           <a:xfrm>
-            <a:off x="640080" y="6053328"/>
+            <a:off x="640080" y="5733288"/>
             <a:ext cx="292608" cy="292608"/>
           </a:xfrm>
           <a:prstGeom prst="rect">
@@ -10180,7 +10180,7 @@
         </p:nvSpPr>
         <p:spPr>
           <a:xfrm>
-            <a:off x="640080" y="6071616"/>
+            <a:off x="640080" y="5751576"/>
             <a:ext cx="292608" cy="256032"/>
           </a:xfrm>
           <a:prstGeom prst="rect">
@@ -10215,7 +10215,7 @@
         </p:nvSpPr>
         <p:spPr>
           <a:xfrm>
-            <a:off x="1051560" y="6035040"/>
+            <a:off x="1051560" y="5715000"/>
             <a:ext cx="6217920" cy="329184"/>
           </a:xfrm>
           <a:prstGeom prst="rect">

</xml_diff>